<commit_message>
update API documentation and presentation
</commit_message>
<xml_diff>
--- a/docs/presentation.pptx
+++ b/docs/presentation.pptx
@@ -7,10 +7,12 @@
   <p:sldIdLst>
     <p:sldId id="256" r:id="rId2"/>
     <p:sldId id="257" r:id="rId3"/>
-    <p:sldId id="258" r:id="rId4"/>
-    <p:sldId id="259" r:id="rId5"/>
-    <p:sldId id="260" r:id="rId6"/>
-    <p:sldId id="261" r:id="rId7"/>
+    <p:sldId id="262" r:id="rId4"/>
+    <p:sldId id="258" r:id="rId5"/>
+    <p:sldId id="263" r:id="rId6"/>
+    <p:sldId id="264" r:id="rId7"/>
+    <p:sldId id="260" r:id="rId8"/>
+    <p:sldId id="261" r:id="rId9"/>
   </p:sldIdLst>
   <p:sldSz cx="12192000" cy="6858000"/>
   <p:notesSz cx="6858000" cy="9144000"/>
@@ -109,6 +111,11 @@
       </a:defRPr>
     </a:lvl9pPr>
   </p:defaultTextStyle>
+  <p:extLst>
+    <p:ext uri="{EFAFB233-063F-42B5-8137-9DF3F51BA10A}">
+      <p15:sldGuideLst xmlns:p15="http://schemas.microsoft.com/office/powerpoint/2012/main"/>
+    </p:ext>
+  </p:extLst>
 </p:presentation>
 </file>
 
@@ -3695,158 +3702,6 @@
           </a:p>
         </p:txBody>
       </p:sp>
-      <p:pic>
-        <p:nvPicPr>
-          <p:cNvPr id="5" name="图片 4">
-            <a:extLst>
-              <a:ext uri="{FF2B5EF4-FFF2-40B4-BE49-F238E27FC236}">
-                <a16:creationId xmlns:a16="http://schemas.microsoft.com/office/drawing/2014/main" id="{CECD5203-F743-6476-95F9-FFFA6D16A407}"/>
-              </a:ext>
-            </a:extLst>
-          </p:cNvPr>
-          <p:cNvPicPr>
-            <a:picLocks noChangeAspect="1"/>
-          </p:cNvPicPr>
-          <p:nvPr/>
-        </p:nvPicPr>
-        <p:blipFill>
-          <a:blip r:embed="rId2">
-            <a:extLst>
-              <a:ext uri="{28A0092B-C50C-407E-A947-70E740481C1C}">
-                <a14:useLocalDpi xmlns:a14="http://schemas.microsoft.com/office/drawing/2010/main" val="0"/>
-              </a:ext>
-            </a:extLst>
-          </a:blip>
-          <a:stretch>
-            <a:fillRect/>
-          </a:stretch>
-        </p:blipFill>
-        <p:spPr>
-          <a:xfrm>
-            <a:off x="6096000" y="3429000"/>
-            <a:ext cx="5107163" cy="3059698"/>
-          </a:xfrm>
-          <a:prstGeom prst="rect">
-            <a:avLst/>
-          </a:prstGeom>
-        </p:spPr>
-      </p:pic>
-      <p:sp>
-        <p:nvSpPr>
-          <p:cNvPr id="6" name="文本框 5">
-            <a:extLst>
-              <a:ext uri="{FF2B5EF4-FFF2-40B4-BE49-F238E27FC236}">
-                <a16:creationId xmlns:a16="http://schemas.microsoft.com/office/drawing/2014/main" id="{8A94F76C-2850-8EEC-EBD9-5B642F3D1FEF}"/>
-              </a:ext>
-            </a:extLst>
-          </p:cNvPr>
-          <p:cNvSpPr txBox="1"/>
-          <p:nvPr/>
-        </p:nvSpPr>
-        <p:spPr>
-          <a:xfrm>
-            <a:off x="627647" y="4702176"/>
-            <a:ext cx="4233111" cy="1631216"/>
-          </a:xfrm>
-          <a:prstGeom prst="rect">
-            <a:avLst/>
-          </a:prstGeom>
-          <a:noFill/>
-        </p:spPr>
-        <p:txBody>
-          <a:bodyPr wrap="square" rtlCol="0">
-            <a:spAutoFit/>
-          </a:bodyPr>
-          <a:lstStyle/>
-          <a:p>
-            <a:r>
-              <a:rPr lang="en-US" altLang="zh-CN" sz="2000" dirty="0"/>
-              <a:t>API Layer (</a:t>
-            </a:r>
-            <a:r>
-              <a:rPr lang="en-US" altLang="zh-CN" sz="2000" dirty="0" err="1"/>
-              <a:t>FastAPI</a:t>
-            </a:r>
-            <a:r>
-              <a:rPr lang="en-US" altLang="zh-CN" sz="2000" dirty="0"/>
-              <a:t>)</a:t>
-            </a:r>
-            <a:br>
-              <a:rPr lang="en-US" altLang="zh-CN" sz="2000" dirty="0"/>
-            </a:br>
-            <a:r>
-              <a:rPr lang="en-US" altLang="zh-CN" sz="2000" dirty="0"/>
-              <a:t>↓</a:t>
-            </a:r>
-            <a:br>
-              <a:rPr lang="en-US" altLang="zh-CN" sz="2000" dirty="0"/>
-            </a:br>
-            <a:r>
-              <a:rPr lang="en-US" altLang="zh-CN" sz="2000" dirty="0"/>
-              <a:t>Business Logic (Routers)</a:t>
-            </a:r>
-            <a:br>
-              <a:rPr lang="en-US" altLang="zh-CN" sz="2000" dirty="0"/>
-            </a:br>
-            <a:r>
-              <a:rPr lang="en-US" altLang="zh-CN" sz="2000" dirty="0"/>
-              <a:t>↓</a:t>
-            </a:r>
-            <a:br>
-              <a:rPr lang="en-US" altLang="zh-CN" sz="2000" dirty="0"/>
-            </a:br>
-            <a:r>
-              <a:rPr lang="en-US" altLang="zh-CN" sz="2000" dirty="0"/>
-              <a:t>Database (SQLite + </a:t>
-            </a:r>
-            <a:r>
-              <a:rPr lang="en-US" altLang="zh-CN" sz="2000" dirty="0" err="1"/>
-              <a:t>SQLAlchemy</a:t>
-            </a:r>
-            <a:r>
-              <a:rPr lang="en-US" altLang="zh-CN" sz="2000" dirty="0"/>
-              <a:t>)</a:t>
-            </a:r>
-            <a:endParaRPr lang="zh-CN" altLang="en-US" sz="2000" dirty="0"/>
-          </a:p>
-        </p:txBody>
-      </p:sp>
-      <p:sp>
-        <p:nvSpPr>
-          <p:cNvPr id="7" name="文本框 6">
-            <a:extLst>
-              <a:ext uri="{FF2B5EF4-FFF2-40B4-BE49-F238E27FC236}">
-                <a16:creationId xmlns:a16="http://schemas.microsoft.com/office/drawing/2014/main" id="{13BA2357-C3FC-9720-1D83-119DBF3585E7}"/>
-              </a:ext>
-            </a:extLst>
-          </p:cNvPr>
-          <p:cNvSpPr txBox="1"/>
-          <p:nvPr/>
-        </p:nvSpPr>
-        <p:spPr>
-          <a:xfrm>
-            <a:off x="627647" y="4174019"/>
-            <a:ext cx="4008520" cy="523220"/>
-          </a:xfrm>
-          <a:prstGeom prst="rect">
-            <a:avLst/>
-          </a:prstGeom>
-          <a:noFill/>
-        </p:spPr>
-        <p:txBody>
-          <a:bodyPr wrap="square" rtlCol="0">
-            <a:spAutoFit/>
-          </a:bodyPr>
-          <a:lstStyle/>
-          <a:p>
-            <a:r>
-              <a:rPr lang="en-US" altLang="zh-CN" sz="2800" b="1" dirty="0"/>
-              <a:t>System Architecture</a:t>
-            </a:r>
-            <a:endParaRPr lang="zh-CN" altLang="en-US" sz="2800" b="1" dirty="0"/>
-          </a:p>
-        </p:txBody>
-      </p:sp>
       <p:sp>
         <p:nvSpPr>
           <p:cNvPr id="8" name="文本框 7">
@@ -3918,7 +3773,7 @@
           <p:cNvPr id="2" name="标题 1">
             <a:extLst>
               <a:ext uri="{FF2B5EF4-FFF2-40B4-BE49-F238E27FC236}">
-                <a16:creationId xmlns:a16="http://schemas.microsoft.com/office/drawing/2014/main" id="{5CDA2CDA-E26D-B381-F7D9-1FB04E34187D}"/>
+                <a16:creationId xmlns:a16="http://schemas.microsoft.com/office/drawing/2014/main" id="{BBA4A28E-CBB0-444B-D665-E612D9307813}"/>
               </a:ext>
             </a:extLst>
           </p:cNvPr>
@@ -3931,114 +3786,95 @@
         </p:nvSpPr>
         <p:spPr>
           <a:xfrm>
-            <a:off x="838200" y="365125"/>
-            <a:ext cx="3445042" cy="1325563"/>
+            <a:off x="752833" y="502630"/>
+            <a:ext cx="10430233" cy="728030"/>
           </a:xfrm>
         </p:spPr>
         <p:txBody>
           <a:bodyPr>
-            <a:normAutofit/>
+            <a:normAutofit fontScale="90000"/>
           </a:bodyPr>
           <a:lstStyle/>
           <a:p>
             <a:r>
-              <a:rPr lang="en-US" altLang="zh-CN" sz="2800" b="1" dirty="0"/>
-              <a:t>Data Source</a:t>
-            </a:r>
-            <a:endParaRPr lang="zh-CN" altLang="en-US" sz="2800" b="1" dirty="0"/>
-          </a:p>
-        </p:txBody>
-      </p:sp>
-      <p:sp>
-        <p:nvSpPr>
-          <p:cNvPr id="3" name="内容占位符 2">
-            <a:extLst>
-              <a:ext uri="{FF2B5EF4-FFF2-40B4-BE49-F238E27FC236}">
-                <a16:creationId xmlns:a16="http://schemas.microsoft.com/office/drawing/2014/main" id="{6C3BF7B9-6C7C-8BC8-1B23-8AF2CCB35C8B}"/>
-              </a:ext>
-            </a:extLst>
-          </p:cNvPr>
-          <p:cNvSpPr>
-            <a:spLocks noGrp="1"/>
-          </p:cNvSpPr>
+              <a:rPr lang="en-US" altLang="zh-CN" b="1" dirty="0"/>
+              <a:t>Version Control &amp; Development Process</a:t>
+            </a:r>
+            <a:br>
+              <a:rPr lang="en-US" altLang="zh-CN" dirty="0"/>
+            </a:br>
+            <a:endParaRPr lang="zh-CN" altLang="en-US" dirty="0"/>
+          </a:p>
+        </p:txBody>
+      </p:sp>
+      <p:pic>
+        <p:nvPicPr>
+          <p:cNvPr id="5" name="内容占位符 4">
+            <a:extLst>
+              <a:ext uri="{FF2B5EF4-FFF2-40B4-BE49-F238E27FC236}">
+                <a16:creationId xmlns:a16="http://schemas.microsoft.com/office/drawing/2014/main" id="{65486466-72DE-E986-819B-433F34A92CF7}"/>
+              </a:ext>
+            </a:extLst>
+          </p:cNvPr>
+          <p:cNvPicPr>
+            <a:picLocks noGrp="1" noChangeAspect="1"/>
+          </p:cNvPicPr>
           <p:nvPr>
             <p:ph idx="1"/>
           </p:nvPr>
-        </p:nvSpPr>
+        </p:nvPicPr>
+        <p:blipFill>
+          <a:blip r:embed="rId2"/>
+          <a:stretch>
+            <a:fillRect/>
+          </a:stretch>
+        </p:blipFill>
         <p:spPr>
           <a:xfrm>
-            <a:off x="838200" y="1376446"/>
-            <a:ext cx="5498433" cy="2489701"/>
+            <a:off x="752833" y="1083423"/>
+            <a:ext cx="4756471" cy="2666433"/>
           </a:xfrm>
+          <a:prstGeom prst="rect">
+            <a:avLst/>
+          </a:prstGeom>
         </p:spPr>
-        <p:txBody>
-          <a:bodyPr>
-            <a:normAutofit fontScale="77500" lnSpcReduction="20000"/>
-          </a:bodyPr>
-          <a:lstStyle/>
-          <a:p>
-            <a:pPr marL="0" indent="0">
-              <a:buNone/>
-            </a:pPr>
-            <a:r>
-              <a:rPr lang="en-US" altLang="zh-CN" dirty="0"/>
-              <a:t>• US DOT On-Time Performance Dataset (2018–2024)</a:t>
-            </a:r>
-          </a:p>
-          <a:p>
-            <a:pPr marL="0" indent="0">
-              <a:buNone/>
-            </a:pPr>
-            <a:r>
-              <a:rPr lang="en-US" altLang="zh-CN" dirty="0"/>
-              <a:t>• Real flight-level data</a:t>
-            </a:r>
-          </a:p>
-          <a:p>
-            <a:pPr marL="0" indent="0">
-              <a:buNone/>
-            </a:pPr>
-            <a:r>
-              <a:rPr lang="en-US" altLang="zh-CN" dirty="0"/>
-              <a:t>• Includes:</a:t>
-            </a:r>
-          </a:p>
-          <a:p>
-            <a:pPr marL="0" indent="0">
-              <a:buNone/>
-            </a:pPr>
-            <a:r>
-              <a:rPr lang="en-US" altLang="zh-CN" dirty="0"/>
-              <a:t>  - origin / destination</a:t>
-            </a:r>
-          </a:p>
-          <a:p>
-            <a:pPr marL="0" indent="0">
-              <a:buNone/>
-            </a:pPr>
-            <a:r>
-              <a:rPr lang="en-US" altLang="zh-CN" dirty="0"/>
-              <a:t>  - departure time</a:t>
-            </a:r>
-          </a:p>
-          <a:p>
-            <a:pPr marL="0" indent="0">
-              <a:buNone/>
-            </a:pPr>
-            <a:r>
-              <a:rPr lang="en-US" altLang="zh-CN" dirty="0"/>
-              <a:t>  - delay information</a:t>
-            </a:r>
-            <a:endParaRPr lang="zh-CN" altLang="en-US" dirty="0"/>
-          </a:p>
-        </p:txBody>
-      </p:sp>
-      <p:sp>
-        <p:nvSpPr>
-          <p:cNvPr id="4" name="文本框 3">
-            <a:extLst>
-              <a:ext uri="{FF2B5EF4-FFF2-40B4-BE49-F238E27FC236}">
-                <a16:creationId xmlns:a16="http://schemas.microsoft.com/office/drawing/2014/main" id="{14A5FFAA-2B90-7D90-F75C-D67692F7174D}"/>
+      </p:pic>
+      <p:pic>
+        <p:nvPicPr>
+          <p:cNvPr id="7" name="图片 6">
+            <a:extLst>
+              <a:ext uri="{FF2B5EF4-FFF2-40B4-BE49-F238E27FC236}">
+                <a16:creationId xmlns:a16="http://schemas.microsoft.com/office/drawing/2014/main" id="{3503E9A9-E0A3-5C94-FF0F-2D38AEA2C97D}"/>
+              </a:ext>
+            </a:extLst>
+          </p:cNvPr>
+          <p:cNvPicPr>
+            <a:picLocks noChangeAspect="1"/>
+          </p:cNvPicPr>
+          <p:nvPr/>
+        </p:nvPicPr>
+        <p:blipFill>
+          <a:blip r:embed="rId3"/>
+          <a:stretch>
+            <a:fillRect/>
+          </a:stretch>
+        </p:blipFill>
+        <p:spPr>
+          <a:xfrm>
+            <a:off x="5996388" y="1083423"/>
+            <a:ext cx="5186678" cy="5627340"/>
+          </a:xfrm>
+          <a:prstGeom prst="rect">
+            <a:avLst/>
+          </a:prstGeom>
+        </p:spPr>
+      </p:pic>
+      <p:sp>
+        <p:nvSpPr>
+          <p:cNvPr id="8" name="文本框 7">
+            <a:extLst>
+              <a:ext uri="{FF2B5EF4-FFF2-40B4-BE49-F238E27FC236}">
+                <a16:creationId xmlns:a16="http://schemas.microsoft.com/office/drawing/2014/main" id="{AEDEA8E2-FE20-BBAA-64FF-DC9A945042AC}"/>
               </a:ext>
             </a:extLst>
           </p:cNvPr>
@@ -4047,8 +3883,8 @@
         </p:nvSpPr>
         <p:spPr>
           <a:xfrm>
-            <a:off x="4090739" y="3212122"/>
-            <a:ext cx="2197769" cy="523220"/>
+            <a:off x="928151" y="4283242"/>
+            <a:ext cx="4063236" cy="1754326"/>
           </a:xfrm>
           <a:prstGeom prst="rect">
             <a:avLst/>
@@ -4061,149 +3897,75 @@
           </a:bodyPr>
           <a:lstStyle/>
           <a:p>
-            <a:r>
-              <a:rPr lang="en-US" altLang="zh-CN" sz="2800" b="1" dirty="0"/>
-              <a:t>API Design</a:t>
-            </a:r>
-            <a:endParaRPr lang="zh-CN" altLang="en-US" sz="2800" b="1" dirty="0"/>
-          </a:p>
-        </p:txBody>
-      </p:sp>
-      <p:sp>
-        <p:nvSpPr>
-          <p:cNvPr id="5" name="文本框 4">
-            <a:extLst>
-              <a:ext uri="{FF2B5EF4-FFF2-40B4-BE49-F238E27FC236}">
-                <a16:creationId xmlns:a16="http://schemas.microsoft.com/office/drawing/2014/main" id="{E329FAA3-2560-223E-2BBF-28EB2945A355}"/>
-              </a:ext>
-            </a:extLst>
-          </p:cNvPr>
-          <p:cNvSpPr txBox="1"/>
-          <p:nvPr/>
-        </p:nvSpPr>
-        <p:spPr>
-          <a:xfrm>
-            <a:off x="4090739" y="3866147"/>
-            <a:ext cx="5133474" cy="2862322"/>
-          </a:xfrm>
-          <a:prstGeom prst="rect">
-            <a:avLst/>
-          </a:prstGeom>
-          <a:noFill/>
-        </p:spPr>
-        <p:txBody>
-          <a:bodyPr wrap="square" rtlCol="0">
-            <a:spAutoFit/>
-          </a:bodyPr>
-          <a:lstStyle/>
-          <a:p>
+            <a:pPr marL="285750" indent="-285750">
+              <a:buFont typeface="Arial" panose="020B0604020202020204" pitchFamily="34" charset="0"/>
+              <a:buChar char="•"/>
+            </a:pPr>
+            <a:r>
+              <a:rPr lang="en-US" altLang="zh-CN" dirty="0" err="1"/>
+              <a:t>init</a:t>
+            </a:r>
             <a:r>
               <a:rPr lang="en-US" altLang="zh-CN" dirty="0"/>
-              <a:t>Flights (CRUD):</a:t>
-            </a:r>
-          </a:p>
-          <a:p>
+              <a:t> project structure</a:t>
+            </a:r>
+          </a:p>
+          <a:p>
+            <a:pPr marL="285750" indent="-285750">
+              <a:buFont typeface="Arial" panose="020B0604020202020204" pitchFamily="34" charset="0"/>
+              <a:buChar char="•"/>
+            </a:pPr>
             <a:r>
               <a:rPr lang="en-US" altLang="zh-CN" dirty="0"/>
-              <a:t>• POST /flights</a:t>
-            </a:r>
-          </a:p>
-          <a:p>
+              <a:t>add flight CRUD endpoints</a:t>
+            </a:r>
+          </a:p>
+          <a:p>
+            <a:pPr marL="285750" indent="-285750">
+              <a:buFont typeface="Arial" panose="020B0604020202020204" pitchFamily="34" charset="0"/>
+              <a:buChar char="•"/>
+            </a:pPr>
             <a:r>
               <a:rPr lang="en-US" altLang="zh-CN" dirty="0"/>
-              <a:t>• GET /flights/{id}</a:t>
-            </a:r>
-          </a:p>
-          <a:p>
+              <a:t>implement delay-rate analytics</a:t>
+            </a:r>
+          </a:p>
+          <a:p>
+            <a:pPr marL="285750" indent="-285750">
+              <a:buFont typeface="Arial" panose="020B0604020202020204" pitchFamily="34" charset="0"/>
+              <a:buChar char="•"/>
+            </a:pPr>
             <a:r>
               <a:rPr lang="en-US" altLang="zh-CN" dirty="0"/>
-              <a:t>• PUT /flights/{id}</a:t>
-            </a:r>
-          </a:p>
-          <a:p>
+              <a:t>fix bug and write docs</a:t>
+            </a:r>
+          </a:p>
+          <a:p>
+            <a:pPr marL="285750" indent="-285750">
+              <a:buFont typeface="Arial" panose="020B0604020202020204" pitchFamily="34" charset="0"/>
+              <a:buChar char="•"/>
+            </a:pPr>
             <a:r>
               <a:rPr lang="en-US" altLang="zh-CN" dirty="0"/>
-              <a:t>• DELETE /flights/{id}</a:t>
-            </a:r>
-          </a:p>
-          <a:p>
-            <a:endParaRPr lang="en-US" altLang="zh-CN" dirty="0"/>
-          </a:p>
-          <a:p>
+              <a:t>add unit tests</a:t>
+            </a:r>
+          </a:p>
+          <a:p>
+            <a:pPr marL="285750" indent="-285750">
+              <a:buFont typeface="Arial" panose="020B0604020202020204" pitchFamily="34" charset="0"/>
+              <a:buChar char="•"/>
+            </a:pPr>
             <a:r>
               <a:rPr lang="en-US" altLang="zh-CN" dirty="0"/>
-              <a:t>Other endpoints:</a:t>
-            </a:r>
-          </a:p>
-          <a:p>
-            <a:r>
-              <a:rPr lang="en-US" altLang="zh-CN" dirty="0"/>
-              <a:t>• /airports/{</a:t>
-            </a:r>
-            <a:r>
-              <a:rPr lang="en-US" altLang="zh-CN" dirty="0" err="1"/>
-              <a:t>iata</a:t>
-            </a:r>
-            <a:r>
-              <a:rPr lang="en-US" altLang="zh-CN" dirty="0"/>
-              <a:t>}/destinations</a:t>
-            </a:r>
-          </a:p>
-          <a:p>
-            <a:r>
-              <a:rPr lang="en-US" altLang="zh-CN" dirty="0"/>
-              <a:t>• /analytics/delay-rate</a:t>
-            </a:r>
-          </a:p>
-          <a:p>
-            <a:r>
-              <a:rPr lang="en-US" altLang="zh-CN" dirty="0"/>
-              <a:t>• /analytics/delay-by-hour</a:t>
-            </a:r>
-            <a:endParaRPr lang="zh-CN" altLang="en-US" dirty="0"/>
-          </a:p>
-        </p:txBody>
-      </p:sp>
-      <p:pic>
-        <p:nvPicPr>
-          <p:cNvPr id="7" name="图片 6">
-            <a:extLst>
-              <a:ext uri="{FF2B5EF4-FFF2-40B4-BE49-F238E27FC236}">
-                <a16:creationId xmlns:a16="http://schemas.microsoft.com/office/drawing/2014/main" id="{A44ECAF3-D9BA-C537-B31E-93475EBF5130}"/>
-              </a:ext>
-            </a:extLst>
-          </p:cNvPr>
-          <p:cNvPicPr>
-            <a:picLocks noChangeAspect="1"/>
-          </p:cNvPicPr>
-          <p:nvPr/>
-        </p:nvPicPr>
-        <p:blipFill>
-          <a:blip r:embed="rId2">
-            <a:extLst>
-              <a:ext uri="{28A0092B-C50C-407E-A947-70E740481C1C}">
-                <a14:useLocalDpi xmlns:a14="http://schemas.microsoft.com/office/drawing/2010/main" val="0"/>
-              </a:ext>
-            </a:extLst>
-          </a:blip>
-          <a:stretch>
-            <a:fillRect/>
-          </a:stretch>
-        </p:blipFill>
-        <p:spPr>
-          <a:xfrm>
-            <a:off x="6657476" y="2379253"/>
-            <a:ext cx="5052822" cy="2841545"/>
-          </a:xfrm>
-          <a:prstGeom prst="rect">
-            <a:avLst/>
-          </a:prstGeom>
-        </p:spPr>
-      </p:pic>
+              <a:t>final check</a:t>
+            </a:r>
+          </a:p>
+        </p:txBody>
+      </p:sp>
     </p:spTree>
     <p:extLst>
       <p:ext uri="{BB962C8B-B14F-4D97-AF65-F5344CB8AC3E}">
-        <p14:creationId xmlns:p14="http://schemas.microsoft.com/office/powerpoint/2010/main" val="572861668"/>
+        <p14:creationId xmlns:p14="http://schemas.microsoft.com/office/powerpoint/2010/main" val="2053630488"/>
       </p:ext>
     </p:extLst>
   </p:cSld>
@@ -4235,7 +3997,7 @@
           <p:cNvPr id="2" name="标题 1">
             <a:extLst>
               <a:ext uri="{FF2B5EF4-FFF2-40B4-BE49-F238E27FC236}">
-                <a16:creationId xmlns:a16="http://schemas.microsoft.com/office/drawing/2014/main" id="{6DEA7588-10D5-7F5B-BDCE-5506B9D05243}"/>
+                <a16:creationId xmlns:a16="http://schemas.microsoft.com/office/drawing/2014/main" id="{5CDA2CDA-E26D-B381-F7D9-1FB04E34187D}"/>
               </a:ext>
             </a:extLst>
           </p:cNvPr>
@@ -4248,8 +4010,8 @@
         </p:nvSpPr>
         <p:spPr>
           <a:xfrm>
-            <a:off x="806116" y="1124136"/>
-            <a:ext cx="2675021" cy="1325563"/>
+            <a:off x="838200" y="365125"/>
+            <a:ext cx="3445042" cy="1325563"/>
           </a:xfrm>
         </p:spPr>
         <p:txBody>
@@ -4260,48 +4022,231 @@
           <a:p>
             <a:r>
               <a:rPr lang="en-US" altLang="zh-CN" sz="2800" b="1" dirty="0"/>
-              <a:t>Features</a:t>
+              <a:t>Data Source</a:t>
             </a:r>
             <a:endParaRPr lang="zh-CN" altLang="en-US" sz="2800" b="1" dirty="0"/>
           </a:p>
         </p:txBody>
       </p:sp>
-      <p:pic>
-        <p:nvPicPr>
-          <p:cNvPr id="5" name="内容占位符 4">
-            <a:extLst>
-              <a:ext uri="{FF2B5EF4-FFF2-40B4-BE49-F238E27FC236}">
-                <a16:creationId xmlns:a16="http://schemas.microsoft.com/office/drawing/2014/main" id="{B1FB0D9D-5D7C-2D8C-2FE1-47498D72F64C}"/>
-              </a:ext>
-            </a:extLst>
-          </p:cNvPr>
-          <p:cNvPicPr>
-            <a:picLocks noGrp="1" noChangeAspect="1"/>
-          </p:cNvPicPr>
+      <p:sp>
+        <p:nvSpPr>
+          <p:cNvPr id="3" name="内容占位符 2">
+            <a:extLst>
+              <a:ext uri="{FF2B5EF4-FFF2-40B4-BE49-F238E27FC236}">
+                <a16:creationId xmlns:a16="http://schemas.microsoft.com/office/drawing/2014/main" id="{6C3BF7B9-6C7C-8BC8-1B23-8AF2CCB35C8B}"/>
+              </a:ext>
+            </a:extLst>
+          </p:cNvPr>
+          <p:cNvSpPr>
+            <a:spLocks noGrp="1"/>
+          </p:cNvSpPr>
           <p:nvPr>
             <p:ph idx="1"/>
           </p:nvPr>
-        </p:nvPicPr>
-        <p:blipFill>
-          <a:blip r:embed="rId2"/>
-          <a:stretch>
-            <a:fillRect/>
-          </a:stretch>
-        </p:blipFill>
+        </p:nvSpPr>
         <p:spPr>
           <a:xfrm>
-            <a:off x="651710" y="2449699"/>
-            <a:ext cx="10888579" cy="1958602"/>
+            <a:off x="838200" y="1376446"/>
+            <a:ext cx="5498433" cy="2489701"/>
+          </a:xfrm>
+        </p:spPr>
+        <p:txBody>
+          <a:bodyPr>
+            <a:normAutofit fontScale="77500" lnSpcReduction="20000"/>
+          </a:bodyPr>
+          <a:lstStyle/>
+          <a:p>
+            <a:pPr marL="0" indent="0">
+              <a:buNone/>
+            </a:pPr>
+            <a:r>
+              <a:rPr lang="en-US" altLang="zh-CN" dirty="0"/>
+              <a:t>• US DOT On-Time Performance Dataset (2018–2024)</a:t>
+            </a:r>
+          </a:p>
+          <a:p>
+            <a:pPr marL="0" indent="0">
+              <a:buNone/>
+            </a:pPr>
+            <a:r>
+              <a:rPr lang="en-US" altLang="zh-CN" dirty="0"/>
+              <a:t>• Real flight-level data</a:t>
+            </a:r>
+          </a:p>
+          <a:p>
+            <a:pPr marL="0" indent="0">
+              <a:buNone/>
+            </a:pPr>
+            <a:r>
+              <a:rPr lang="en-US" altLang="zh-CN" dirty="0"/>
+              <a:t>• Includes:</a:t>
+            </a:r>
+          </a:p>
+          <a:p>
+            <a:pPr marL="0" indent="0">
+              <a:buNone/>
+            </a:pPr>
+            <a:r>
+              <a:rPr lang="en-US" altLang="zh-CN" dirty="0"/>
+              <a:t>  - origin / destination</a:t>
+            </a:r>
+          </a:p>
+          <a:p>
+            <a:pPr marL="0" indent="0">
+              <a:buNone/>
+            </a:pPr>
+            <a:r>
+              <a:rPr lang="en-US" altLang="zh-CN" dirty="0"/>
+              <a:t>  - departure time</a:t>
+            </a:r>
+          </a:p>
+          <a:p>
+            <a:pPr marL="0" indent="0">
+              <a:buNone/>
+            </a:pPr>
+            <a:r>
+              <a:rPr lang="en-US" altLang="zh-CN" dirty="0"/>
+              <a:t>  - delay information</a:t>
+            </a:r>
+            <a:endParaRPr lang="zh-CN" altLang="en-US" dirty="0"/>
+          </a:p>
+        </p:txBody>
+      </p:sp>
+      <p:sp>
+        <p:nvSpPr>
+          <p:cNvPr id="4" name="文本框 3">
+            <a:extLst>
+              <a:ext uri="{FF2B5EF4-FFF2-40B4-BE49-F238E27FC236}">
+                <a16:creationId xmlns:a16="http://schemas.microsoft.com/office/drawing/2014/main" id="{14A5FFAA-2B90-7D90-F75C-D67692F7174D}"/>
+              </a:ext>
+            </a:extLst>
+          </p:cNvPr>
+          <p:cNvSpPr txBox="1"/>
+          <p:nvPr/>
+        </p:nvSpPr>
+        <p:spPr>
+          <a:xfrm>
+            <a:off x="7617711" y="766296"/>
+            <a:ext cx="2197769" cy="523220"/>
           </a:xfrm>
           <a:prstGeom prst="rect">
             <a:avLst/>
           </a:prstGeom>
+          <a:noFill/>
         </p:spPr>
-      </p:pic>
+        <p:txBody>
+          <a:bodyPr wrap="square" rtlCol="0">
+            <a:spAutoFit/>
+          </a:bodyPr>
+          <a:lstStyle/>
+          <a:p>
+            <a:r>
+              <a:rPr lang="en-US" altLang="zh-CN" sz="2800" b="1" dirty="0"/>
+              <a:t>API Design</a:t>
+            </a:r>
+            <a:endParaRPr lang="zh-CN" altLang="en-US" sz="2800" b="1" dirty="0"/>
+          </a:p>
+        </p:txBody>
+      </p:sp>
+      <p:sp>
+        <p:nvSpPr>
+          <p:cNvPr id="5" name="文本框 4">
+            <a:extLst>
+              <a:ext uri="{FF2B5EF4-FFF2-40B4-BE49-F238E27FC236}">
+                <a16:creationId xmlns:a16="http://schemas.microsoft.com/office/drawing/2014/main" id="{E329FAA3-2560-223E-2BBF-28EB2945A355}"/>
+              </a:ext>
+            </a:extLst>
+          </p:cNvPr>
+          <p:cNvSpPr txBox="1"/>
+          <p:nvPr/>
+        </p:nvSpPr>
+        <p:spPr>
+          <a:xfrm>
+            <a:off x="7617711" y="1376446"/>
+            <a:ext cx="5133474" cy="2862322"/>
+          </a:xfrm>
+          <a:prstGeom prst="rect">
+            <a:avLst/>
+          </a:prstGeom>
+          <a:noFill/>
+        </p:spPr>
+        <p:txBody>
+          <a:bodyPr wrap="square" rtlCol="0">
+            <a:spAutoFit/>
+          </a:bodyPr>
+          <a:lstStyle/>
+          <a:p>
+            <a:r>
+              <a:rPr lang="en-US" altLang="zh-CN" dirty="0"/>
+              <a:t>Flights (CRUD):</a:t>
+            </a:r>
+          </a:p>
+          <a:p>
+            <a:r>
+              <a:rPr lang="en-US" altLang="zh-CN" dirty="0"/>
+              <a:t>• POST /flights</a:t>
+            </a:r>
+          </a:p>
+          <a:p>
+            <a:r>
+              <a:rPr lang="en-US" altLang="zh-CN" dirty="0"/>
+              <a:t>• GET /flights/{id}</a:t>
+            </a:r>
+          </a:p>
+          <a:p>
+            <a:r>
+              <a:rPr lang="en-US" altLang="zh-CN" dirty="0"/>
+              <a:t>• PUT /flights/{id}</a:t>
+            </a:r>
+          </a:p>
+          <a:p>
+            <a:r>
+              <a:rPr lang="en-US" altLang="zh-CN" dirty="0"/>
+              <a:t>• DELETE /flights/{id}</a:t>
+            </a:r>
+          </a:p>
+          <a:p>
+            <a:endParaRPr lang="en-US" altLang="zh-CN" dirty="0"/>
+          </a:p>
+          <a:p>
+            <a:r>
+              <a:rPr lang="en-US" altLang="zh-CN" dirty="0"/>
+              <a:t>Other endpoints:</a:t>
+            </a:r>
+          </a:p>
+          <a:p>
+            <a:r>
+              <a:rPr lang="en-US" altLang="zh-CN" dirty="0"/>
+              <a:t>• /airports/{</a:t>
+            </a:r>
+            <a:r>
+              <a:rPr lang="en-US" altLang="zh-CN" dirty="0" err="1"/>
+              <a:t>iata</a:t>
+            </a:r>
+            <a:r>
+              <a:rPr lang="en-US" altLang="zh-CN" dirty="0"/>
+              <a:t>}/destinations</a:t>
+            </a:r>
+          </a:p>
+          <a:p>
+            <a:r>
+              <a:rPr lang="en-US" altLang="zh-CN" dirty="0"/>
+              <a:t>• /analytics/delay-rate</a:t>
+            </a:r>
+          </a:p>
+          <a:p>
+            <a:r>
+              <a:rPr lang="en-US" altLang="zh-CN" dirty="0"/>
+              <a:t>• /analytics/delay-by-hour</a:t>
+            </a:r>
+            <a:endParaRPr lang="zh-CN" altLang="en-US" dirty="0"/>
+          </a:p>
+        </p:txBody>
+      </p:sp>
     </p:spTree>
     <p:extLst>
       <p:ext uri="{BB962C8B-B14F-4D97-AF65-F5344CB8AC3E}">
-        <p14:creationId xmlns:p14="http://schemas.microsoft.com/office/powerpoint/2010/main" val="4034228818"/>
+        <p14:creationId xmlns:p14="http://schemas.microsoft.com/office/powerpoint/2010/main" val="572861668"/>
       </p:ext>
     </p:extLst>
   </p:cSld>
@@ -4333,6 +4278,367 @@
           <p:cNvPr id="2" name="标题 1">
             <a:extLst>
               <a:ext uri="{FF2B5EF4-FFF2-40B4-BE49-F238E27FC236}">
+                <a16:creationId xmlns:a16="http://schemas.microsoft.com/office/drawing/2014/main" id="{73AE22EE-FAE4-656D-5CE0-60B22E82F7BD}"/>
+              </a:ext>
+            </a:extLst>
+          </p:cNvPr>
+          <p:cNvSpPr>
+            <a:spLocks noGrp="1"/>
+          </p:cNvSpPr>
+          <p:nvPr>
+            <p:ph type="title"/>
+          </p:nvPr>
+        </p:nvSpPr>
+        <p:spPr/>
+        <p:txBody>
+          <a:bodyPr>
+            <a:normAutofit/>
+          </a:bodyPr>
+          <a:lstStyle/>
+          <a:p>
+            <a:r>
+              <a:rPr lang="en-US" altLang="zh-CN" sz="2800" b="1" dirty="0"/>
+              <a:t>API Documentation</a:t>
+            </a:r>
+            <a:endParaRPr lang="zh-CN" altLang="en-US" sz="2800" b="1" dirty="0"/>
+          </a:p>
+        </p:txBody>
+      </p:sp>
+      <p:sp>
+        <p:nvSpPr>
+          <p:cNvPr id="3" name="内容占位符 2">
+            <a:extLst>
+              <a:ext uri="{FF2B5EF4-FFF2-40B4-BE49-F238E27FC236}">
+                <a16:creationId xmlns:a16="http://schemas.microsoft.com/office/drawing/2014/main" id="{C287E7CB-F1B5-BC9F-3E9C-A116A1597460}"/>
+              </a:ext>
+            </a:extLst>
+          </p:cNvPr>
+          <p:cNvSpPr>
+            <a:spLocks noGrp="1"/>
+          </p:cNvSpPr>
+          <p:nvPr>
+            <p:ph idx="1"/>
+          </p:nvPr>
+        </p:nvSpPr>
+        <p:spPr>
+          <a:xfrm>
+            <a:off x="838200" y="1825625"/>
+            <a:ext cx="4043183" cy="1687596"/>
+          </a:xfrm>
+        </p:spPr>
+        <p:txBody>
+          <a:bodyPr>
+            <a:normAutofit fontScale="47500" lnSpcReduction="20000"/>
+          </a:bodyPr>
+          <a:lstStyle/>
+          <a:p>
+            <a:pPr marL="0" indent="0">
+              <a:buNone/>
+            </a:pPr>
+            <a:r>
+              <a:rPr lang="en-US" altLang="zh-CN" dirty="0"/>
+              <a:t>- Endpoints  </a:t>
+            </a:r>
+          </a:p>
+          <a:p>
+            <a:pPr marL="0" indent="0">
+              <a:buNone/>
+            </a:pPr>
+            <a:r>
+              <a:rPr lang="en-US" altLang="zh-CN" dirty="0"/>
+              <a:t>- Parameters  </a:t>
+            </a:r>
+          </a:p>
+          <a:p>
+            <a:pPr marL="0" indent="0">
+              <a:buNone/>
+            </a:pPr>
+            <a:r>
+              <a:rPr lang="en-US" altLang="zh-CN" dirty="0"/>
+              <a:t>- JSON response formats  </a:t>
+            </a:r>
+          </a:p>
+          <a:p>
+            <a:pPr>
+              <a:buFontTx/>
+              <a:buChar char="-"/>
+            </a:pPr>
+            <a:r>
+              <a:rPr lang="en-US" altLang="zh-CN" dirty="0"/>
+              <a:t>Example requests and responses</a:t>
+            </a:r>
+          </a:p>
+          <a:p>
+            <a:pPr marL="0" indent="0">
+              <a:buNone/>
+            </a:pPr>
+            <a:endParaRPr lang="en-US" altLang="zh-CN" dirty="0"/>
+          </a:p>
+          <a:p>
+            <a:pPr marL="0" indent="0">
+              <a:buNone/>
+            </a:pPr>
+            <a:r>
+              <a:rPr lang="en-US" altLang="zh-CN" dirty="0"/>
+              <a:t>- Authentication and error handling documented</a:t>
+            </a:r>
+            <a:endParaRPr lang="zh-CN" altLang="en-US" dirty="0"/>
+          </a:p>
+        </p:txBody>
+      </p:sp>
+      <p:pic>
+        <p:nvPicPr>
+          <p:cNvPr id="5" name="图片 4">
+            <a:extLst>
+              <a:ext uri="{FF2B5EF4-FFF2-40B4-BE49-F238E27FC236}">
+                <a16:creationId xmlns:a16="http://schemas.microsoft.com/office/drawing/2014/main" id="{4B8FFF90-BB5F-6CC4-1920-AC48C5224CB4}"/>
+              </a:ext>
+            </a:extLst>
+          </p:cNvPr>
+          <p:cNvPicPr>
+            <a:picLocks noChangeAspect="1"/>
+          </p:cNvPicPr>
+          <p:nvPr/>
+        </p:nvPicPr>
+        <p:blipFill>
+          <a:blip r:embed="rId2"/>
+          <a:stretch>
+            <a:fillRect/>
+          </a:stretch>
+        </p:blipFill>
+        <p:spPr>
+          <a:xfrm>
+            <a:off x="7699885" y="4180114"/>
+            <a:ext cx="3653915" cy="2030878"/>
+          </a:xfrm>
+          <a:prstGeom prst="rect">
+            <a:avLst/>
+          </a:prstGeom>
+        </p:spPr>
+      </p:pic>
+      <p:pic>
+        <p:nvPicPr>
+          <p:cNvPr id="7" name="图片 6">
+            <a:extLst>
+              <a:ext uri="{FF2B5EF4-FFF2-40B4-BE49-F238E27FC236}">
+                <a16:creationId xmlns:a16="http://schemas.microsoft.com/office/drawing/2014/main" id="{1C0077A8-10FE-7361-2357-32716EB95650}"/>
+              </a:ext>
+            </a:extLst>
+          </p:cNvPr>
+          <p:cNvPicPr>
+            <a:picLocks noChangeAspect="1"/>
+          </p:cNvPicPr>
+          <p:nvPr/>
+        </p:nvPicPr>
+        <p:blipFill>
+          <a:blip r:embed="rId3"/>
+          <a:stretch>
+            <a:fillRect/>
+          </a:stretch>
+        </p:blipFill>
+        <p:spPr>
+          <a:xfrm>
+            <a:off x="1467350" y="3815321"/>
+            <a:ext cx="2784881" cy="2567474"/>
+          </a:xfrm>
+          <a:prstGeom prst="rect">
+            <a:avLst/>
+          </a:prstGeom>
+        </p:spPr>
+      </p:pic>
+      <p:pic>
+        <p:nvPicPr>
+          <p:cNvPr id="9" name="图片 8">
+            <a:extLst>
+              <a:ext uri="{FF2B5EF4-FFF2-40B4-BE49-F238E27FC236}">
+                <a16:creationId xmlns:a16="http://schemas.microsoft.com/office/drawing/2014/main" id="{812FB4A9-42F2-77E6-6966-D67ADABB247A}"/>
+              </a:ext>
+            </a:extLst>
+          </p:cNvPr>
+          <p:cNvPicPr>
+            <a:picLocks noChangeAspect="1"/>
+          </p:cNvPicPr>
+          <p:nvPr/>
+        </p:nvPicPr>
+        <p:blipFill>
+          <a:blip r:embed="rId4"/>
+          <a:stretch>
+            <a:fillRect/>
+          </a:stretch>
+        </p:blipFill>
+        <p:spPr>
+          <a:xfrm>
+            <a:off x="5771271" y="1096908"/>
+            <a:ext cx="5146527" cy="2105021"/>
+          </a:xfrm>
+          <a:prstGeom prst="rect">
+            <a:avLst/>
+          </a:prstGeom>
+        </p:spPr>
+      </p:pic>
+    </p:spTree>
+    <p:extLst>
+      <p:ext uri="{BB962C8B-B14F-4D97-AF65-F5344CB8AC3E}">
+        <p14:creationId xmlns:p14="http://schemas.microsoft.com/office/powerpoint/2010/main" val="1445175546"/>
+      </p:ext>
+    </p:extLst>
+  </p:cSld>
+  <p:clrMapOvr>
+    <a:masterClrMapping/>
+  </p:clrMapOvr>
+</p:sld>
+</file>
+
+<file path=ppt/slides/slide6.xml><?xml version="1.0" encoding="utf-8"?>
+<p:sld xmlns:a="http://schemas.openxmlformats.org/drawingml/2006/main" xmlns:r="http://schemas.openxmlformats.org/officeDocument/2006/relationships" xmlns:p="http://schemas.openxmlformats.org/presentationml/2006/main">
+  <p:cSld>
+    <p:spTree>
+      <p:nvGrpSpPr>
+        <p:cNvPr id="1" name=""/>
+        <p:cNvGrpSpPr/>
+        <p:nvPr/>
+      </p:nvGrpSpPr>
+      <p:grpSpPr>
+        <a:xfrm>
+          <a:off x="0" y="0"/>
+          <a:ext cx="0" cy="0"/>
+          <a:chOff x="0" y="0"/>
+          <a:chExt cx="0" cy="0"/>
+        </a:xfrm>
+      </p:grpSpPr>
+      <p:sp>
+        <p:nvSpPr>
+          <p:cNvPr id="2" name="标题 1">
+            <a:extLst>
+              <a:ext uri="{FF2B5EF4-FFF2-40B4-BE49-F238E27FC236}">
+                <a16:creationId xmlns:a16="http://schemas.microsoft.com/office/drawing/2014/main" id="{2469ABED-765F-9C3C-794D-CEC559178DB2}"/>
+              </a:ext>
+            </a:extLst>
+          </p:cNvPr>
+          <p:cNvSpPr>
+            <a:spLocks noGrp="1"/>
+          </p:cNvSpPr>
+          <p:nvPr>
+            <p:ph type="title"/>
+          </p:nvPr>
+        </p:nvSpPr>
+        <p:spPr>
+          <a:xfrm>
+            <a:off x="838200" y="365125"/>
+            <a:ext cx="7185144" cy="1325563"/>
+          </a:xfrm>
+        </p:spPr>
+        <p:txBody>
+          <a:bodyPr/>
+          <a:lstStyle/>
+          <a:p>
+            <a:r>
+              <a:rPr lang="en-US" altLang="zh-CN" dirty="0"/>
+              <a:t>Technical Report Highlights</a:t>
+            </a:r>
+            <a:endParaRPr lang="zh-CN" altLang="en-US" dirty="0"/>
+          </a:p>
+        </p:txBody>
+      </p:sp>
+      <p:sp>
+        <p:nvSpPr>
+          <p:cNvPr id="3" name="内容占位符 2">
+            <a:extLst>
+              <a:ext uri="{FF2B5EF4-FFF2-40B4-BE49-F238E27FC236}">
+                <a16:creationId xmlns:a16="http://schemas.microsoft.com/office/drawing/2014/main" id="{7BA515CF-81C1-1D6D-5A47-7C35842BF21A}"/>
+              </a:ext>
+            </a:extLst>
+          </p:cNvPr>
+          <p:cNvSpPr>
+            <a:spLocks noGrp="1"/>
+          </p:cNvSpPr>
+          <p:nvPr>
+            <p:ph idx="1"/>
+          </p:nvPr>
+        </p:nvSpPr>
+        <p:spPr>
+          <a:xfrm>
+            <a:off x="838200" y="2361890"/>
+            <a:ext cx="9330203" cy="2794501"/>
+          </a:xfrm>
+        </p:spPr>
+        <p:txBody>
+          <a:bodyPr/>
+          <a:lstStyle/>
+          <a:p>
+            <a:pPr marL="0" indent="0">
+              <a:buNone/>
+            </a:pPr>
+            <a:r>
+              <a:rPr lang="en-US" altLang="zh-CN" dirty="0"/>
+              <a:t>• Describes system architecture and design decisions</a:t>
+            </a:r>
+          </a:p>
+          <a:p>
+            <a:pPr marL="0" indent="0">
+              <a:buNone/>
+            </a:pPr>
+            <a:r>
+              <a:rPr lang="en-US" altLang="zh-CN" dirty="0"/>
+              <a:t>• Explains data processing and dataset integration</a:t>
+            </a:r>
+          </a:p>
+          <a:p>
+            <a:pPr marL="0" indent="0">
+              <a:buNone/>
+            </a:pPr>
+            <a:r>
+              <a:rPr lang="en-US" altLang="zh-CN" dirty="0"/>
+              <a:t>• Details API implementation and analytics logic</a:t>
+            </a:r>
+          </a:p>
+          <a:p>
+            <a:pPr marL="0" indent="0">
+              <a:buNone/>
+            </a:pPr>
+            <a:r>
+              <a:rPr lang="en-US" altLang="zh-CN" dirty="0"/>
+              <a:t>• Discusses challenges and future improvements</a:t>
+            </a:r>
+            <a:endParaRPr lang="zh-CN" altLang="en-US" dirty="0"/>
+          </a:p>
+        </p:txBody>
+      </p:sp>
+    </p:spTree>
+    <p:extLst>
+      <p:ext uri="{BB962C8B-B14F-4D97-AF65-F5344CB8AC3E}">
+        <p14:creationId xmlns:p14="http://schemas.microsoft.com/office/powerpoint/2010/main" val="21264825"/>
+      </p:ext>
+    </p:extLst>
+  </p:cSld>
+  <p:clrMapOvr>
+    <a:masterClrMapping/>
+  </p:clrMapOvr>
+</p:sld>
+</file>
+
+<file path=ppt/slides/slide7.xml><?xml version="1.0" encoding="utf-8"?>
+<p:sld xmlns:a="http://schemas.openxmlformats.org/drawingml/2006/main" xmlns:r="http://schemas.openxmlformats.org/officeDocument/2006/relationships" xmlns:p="http://schemas.openxmlformats.org/presentationml/2006/main">
+  <p:cSld>
+    <p:spTree>
+      <p:nvGrpSpPr>
+        <p:cNvPr id="1" name=""/>
+        <p:cNvGrpSpPr/>
+        <p:nvPr/>
+      </p:nvGrpSpPr>
+      <p:grpSpPr>
+        <a:xfrm>
+          <a:off x="0" y="0"/>
+          <a:ext cx="0" cy="0"/>
+          <a:chOff x="0" y="0"/>
+          <a:chExt cx="0" cy="0"/>
+        </a:xfrm>
+      </p:grpSpPr>
+      <p:sp>
+        <p:nvSpPr>
+          <p:cNvPr id="2" name="标题 1">
+            <a:extLst>
+              <a:ext uri="{FF2B5EF4-FFF2-40B4-BE49-F238E27FC236}">
                 <a16:creationId xmlns:a16="http://schemas.microsoft.com/office/drawing/2014/main" id="{7DDED919-A75E-93A5-F846-FD5B94DB27CC}"/>
               </a:ext>
             </a:extLst>
@@ -4377,7 +4683,7 @@
 </p:sld>
 </file>
 
-<file path=ppt/slides/slide6.xml><?xml version="1.0" encoding="utf-8"?>
+<file path=ppt/slides/slide8.xml><?xml version="1.0" encoding="utf-8"?>
 <p:sld xmlns:a="http://schemas.openxmlformats.org/drawingml/2006/main" xmlns:r="http://schemas.openxmlformats.org/officeDocument/2006/relationships" xmlns:p="http://schemas.openxmlformats.org/presentationml/2006/main">
   <p:cSld>
     <p:spTree>

</xml_diff>